<commit_message>
Shorten AI usage acknowledgement to the wording approved by the teacher
</commit_message>
<xml_diff>
--- a/report/Activity_2_Presentation.pptx
+++ b/report/Activity_2_Presentation.pptx
@@ -4109,99 +4109,25 @@
           </a:bodyPr>
           <a:lstStyle/>
           <a:p>
-            <a:pPr marL="342900" indent="-342900">
+            <a:pPr>
               <a:spcAft>
                 <a:spcPts val="1300"/>
               </a:spcAft>
-              <a:buFont typeface="Arial"/>
-              <a:buChar char="•"/>
-              <a:defRPr sz="1800">
-                <a:solidFill>
-                  <a:srgbClr val="2D2D2D"/>
-                </a:solidFill>
-                <a:latin typeface="Arial" panose="020B0604020202020204"/>
-              </a:defRPr>
-            </a:pPr>
-            <a:r>
-              <a:rPr sz="1800">
+              <a:defRPr sz="2000">
+                <a:solidFill>
+                  <a:srgbClr val="2D2D2D"/>
+                </a:solidFill>
+                <a:latin typeface="Arial" panose="020B0604020202020204"/>
+              </a:defRPr>
+            </a:pPr>
+            <a:r>
+              <a:rPr sz="2000">
                 <a:solidFill>
                   <a:srgbClr val="2D2D2D"/>
                 </a:solidFill>
                 <a:latin typeface="Arial"/>
               </a:rPr>
-              <a:t>Claude (Anthropic's Claude Code) was used throughout: implementing and debugging all 5 modules, building the evaluation harness, drafting this report/deck, and literature search</a:t>
-            </a:r>
-          </a:p>
-          <a:p>
-            <a:pPr marL="342900" indent="-342900">
-              <a:spcAft>
-                <a:spcPts val="1300"/>
-              </a:spcAft>
-              <a:buFont typeface="Arial"/>
-              <a:buChar char="•"/>
-              <a:defRPr sz="1800">
-                <a:solidFill>
-                  <a:srgbClr val="2D2D2D"/>
-                </a:solidFill>
-                <a:latin typeface="Arial" panose="020B0604020202020204"/>
-              </a:defRPr>
-            </a:pPr>
-            <a:r>
-              <a:rPr sz="1800">
-                <a:solidFill>
-                  <a:srgbClr val="2D2D2D"/>
-                </a:solidFill>
-                <a:latin typeface="Arial"/>
-              </a:rPr>
-              <a:t>All code was executed and tested by the team against real data at every step; every metric shown here comes from actually running the code</a:t>
-            </a:r>
-          </a:p>
-          <a:p>
-            <a:pPr marL="342900" indent="-342900">
-              <a:spcAft>
-                <a:spcPts val="1300"/>
-              </a:spcAft>
-              <a:buFont typeface="Arial"/>
-              <a:buChar char="•"/>
-              <a:defRPr sz="1800">
-                <a:solidFill>
-                  <a:srgbClr val="2D2D2D"/>
-                </a:solidFill>
-                <a:latin typeface="Arial" panose="020B0604020202020204"/>
-              </a:defRPr>
-            </a:pPr>
-            <a:r>
-              <a:rPr sz="1800">
-                <a:solidFill>
-                  <a:srgbClr val="2D2D2D"/>
-                </a:solidFill>
-                <a:latin typeface="Arial"/>
-              </a:rPr>
-              <a:t>Bugs found during testing (e.g. the single-letter spelling-correction issue) were fixed and re-verified</a:t>
-            </a:r>
-          </a:p>
-          <a:p>
-            <a:pPr marL="342900" indent="-342900">
-              <a:spcAft>
-                <a:spcPts val="1300"/>
-              </a:spcAft>
-              <a:buFont typeface="Arial"/>
-              <a:buChar char="•"/>
-              <a:defRPr sz="1800">
-                <a:solidFill>
-                  <a:srgbClr val="2D2D2D"/>
-                </a:solidFill>
-                <a:latin typeface="Arial" panose="020B0604020202020204"/>
-              </a:defRPr>
-            </a:pPr>
-            <a:r>
-              <a:rPr sz="1800">
-                <a:solidFill>
-                  <a:srgbClr val="2D2D2D"/>
-                </a:solidFill>
-                <a:latin typeface="Arial"/>
-              </a:rPr>
-              <a:t>The team takes full responsibility for the correctness of the final code, results, and this report</a:t>
+              <a:t>This project was developed with the assistance of Claude (Anthropic), an AI tool, which was used for code implementation and debugging.</a:t>
             </a:r>
           </a:p>
         </p:txBody>

</xml_diff>